<commit_message>
Strengthen opening, add credibility anchors, apply Pyramid Principle titles
- Replace self-intro opening with customer-pain-first hook (prior tool failure)
- Add sourced credibility numbers: Cisco 1,500 hrs/month, DX Research 91→49 days
- Apply McKinsey Pyramid Principle to all slide titles (conclusions, not labels)
- Tighten Move 3 dashboard demo to ~45 seconds
- Strengthen close with forward momentum ("pilot in two weeks")
- Cascade changes to 20-min script, defense notes, runbook, loom checklist

Co-Authored-By: Claude Opus 4.6 <noreply@anthropic.com>
</commit_message>
<xml_diff>
--- a/codex/codex_enablement_v2.pptx
+++ b/codex/codex_enablement_v2.pptx
@@ -3574,7 +3574,7 @@
               </a:defRPr>
             </a:pPr>
             <a:r>
-              <a:t>What We Heard + The Insight</a:t>
+              <a:t>Four Problems. One Root Cause.</a:t>
             </a:r>
           </a:p>
         </p:txBody>
@@ -4205,7 +4205,7 @@
               </a:defRPr>
             </a:pPr>
             <a:r>
-              <a:t>How Codex Works — and Why It's Different</a:t>
+              <a:t>Agentic. Sandboxed. Every Action Audited.</a:t>
             </a:r>
           </a:p>
         </p:txBody>
@@ -5385,7 +5385,7 @@
               </a:defRPr>
             </a:pPr>
             <a:r>
-              <a:t>The Harness — Governance Architecture</a:t>
+              <a:t>Your Standards Become the AI’s Operating Rules</a:t>
             </a:r>
           </a:p>
         </p:txBody>
@@ -7161,7 +7161,7 @@
               </a:defRPr>
             </a:pPr>
             <a:r>
-              <a:t>Enablement — Three Workflows, Phased Rollout</a:t>
+              <a:t>Start Read-Only. Scale on Evidence.</a:t>
             </a:r>
           </a:p>
         </p:txBody>
@@ -7692,7 +7692,112 @@
       </p:sp>
       <p:sp>
         <p:nvSpPr>
-          <p:cNvPr id="19" name="Rounded Rectangle 18"/>
+          <p:cNvPr id="19" name="TextBox 18"/>
+          <p:cNvSpPr txBox="1"/>
+          <p:nvPr/>
+        </p:nvSpPr>
+        <p:spPr>
+          <a:xfrm>
+            <a:off x="594360" y="4379975"/>
+            <a:ext cx="3291840" cy="274320"/>
+          </a:xfrm>
+          <a:prstGeom prst="rect">
+            <a:avLst/>
+          </a:prstGeom>
+          <a:noFill/>
+        </p:spPr>
+        <p:txBody>
+          <a:bodyPr wrap="square">
+            <a:spAutoFit/>
+          </a:bodyPr>
+          <a:lstStyle/>
+          <a:p>
+            <a:pPr algn="l">
+              <a:defRPr sz="1100" b="0" i="0">
+                <a:solidFill>
+                  <a:srgbClr val="2D2D2D"/>
+                </a:solidFill>
+                <a:latin typeface="Calibri"/>
+              </a:defRPr>
+            </a:pPr>
+          </a:p>
+        </p:txBody>
+      </p:sp>
+      <p:sp>
+        <p:nvSpPr>
+          <p:cNvPr id="20" name="TextBox 19"/>
+          <p:cNvSpPr txBox="1"/>
+          <p:nvPr/>
+        </p:nvSpPr>
+        <p:spPr>
+          <a:xfrm>
+            <a:off x="594360" y="4617719"/>
+            <a:ext cx="3291840" cy="274320"/>
+          </a:xfrm>
+          <a:prstGeom prst="rect">
+            <a:avLst/>
+          </a:prstGeom>
+          <a:noFill/>
+        </p:spPr>
+        <p:txBody>
+          <a:bodyPr wrap="square">
+            <a:spAutoFit/>
+          </a:bodyPr>
+          <a:lstStyle/>
+          <a:p>
+            <a:pPr algn="l">
+              <a:defRPr sz="1100" b="0" i="0">
+                <a:solidFill>
+                  <a:srgbClr val="2D2D2D"/>
+                </a:solidFill>
+                <a:latin typeface="Calibri"/>
+              </a:defRPr>
+            </a:pPr>
+            <a:r>
+              <a:t>Cisco: 1,500 hrs/month saved</a:t>
+            </a:r>
+          </a:p>
+        </p:txBody>
+      </p:sp>
+      <p:sp>
+        <p:nvSpPr>
+          <p:cNvPr id="21" name="TextBox 20"/>
+          <p:cNvSpPr txBox="1"/>
+          <p:nvPr/>
+        </p:nvSpPr>
+        <p:spPr>
+          <a:xfrm>
+            <a:off x="594360" y="4855463"/>
+            <a:ext cx="3291840" cy="274320"/>
+          </a:xfrm>
+          <a:prstGeom prst="rect">
+            <a:avLst/>
+          </a:prstGeom>
+          <a:noFill/>
+        </p:spPr>
+        <p:txBody>
+          <a:bodyPr wrap="square">
+            <a:spAutoFit/>
+          </a:bodyPr>
+          <a:lstStyle/>
+          <a:p>
+            <a:pPr algn="l">
+              <a:defRPr sz="1100" b="0" i="0">
+                <a:solidFill>
+                  <a:srgbClr val="2D2D2D"/>
+                </a:solidFill>
+                <a:latin typeface="Calibri"/>
+              </a:defRPr>
+            </a:pPr>
+            <a:r>
+              <a:t>Onboarding: 91→49 days (DX Research)</a:t>
+            </a:r>
+          </a:p>
+        </p:txBody>
+      </p:sp>
+      <p:sp>
+        <p:nvSpPr>
+          <p:cNvPr id="22" name="Rounded Rectangle 21"/>
           <p:cNvSpPr/>
           <p:nvPr/>
         </p:nvSpPr>
@@ -7737,7 +7842,7 @@
       </p:sp>
       <p:sp>
         <p:nvSpPr>
-          <p:cNvPr id="20" name="TextBox 19"/>
+          <p:cNvPr id="23" name="TextBox 22"/>
           <p:cNvSpPr txBox="1"/>
           <p:nvPr/>
         </p:nvSpPr>
@@ -7773,7 +7878,7 @@
       </p:sp>
       <p:sp>
         <p:nvSpPr>
-          <p:cNvPr id="21" name="TextBox 20"/>
+          <p:cNvPr id="24" name="TextBox 23"/>
           <p:cNvSpPr txBox="1"/>
           <p:nvPr/>
         </p:nvSpPr>
@@ -7809,7 +7914,7 @@
       </p:sp>
       <p:sp>
         <p:nvSpPr>
-          <p:cNvPr id="22" name="Rectangle 21"/>
+          <p:cNvPr id="25" name="Rectangle 24"/>
           <p:cNvSpPr/>
           <p:nvPr/>
         </p:nvSpPr>
@@ -7852,7 +7957,7 @@
       </p:sp>
       <p:sp>
         <p:nvSpPr>
-          <p:cNvPr id="23" name="TextBox 22"/>
+          <p:cNvPr id="26" name="TextBox 25"/>
           <p:cNvSpPr txBox="1"/>
           <p:nvPr/>
         </p:nvSpPr>
@@ -7888,7 +7993,7 @@
       </p:sp>
       <p:sp>
         <p:nvSpPr>
-          <p:cNvPr id="24" name="TextBox 23"/>
+          <p:cNvPr id="27" name="TextBox 26"/>
           <p:cNvSpPr txBox="1"/>
           <p:nvPr/>
         </p:nvSpPr>
@@ -7924,7 +8029,7 @@
       </p:sp>
       <p:sp>
         <p:nvSpPr>
-          <p:cNvPr id="25" name="TextBox 24"/>
+          <p:cNvPr id="28" name="TextBox 27"/>
           <p:cNvSpPr txBox="1"/>
           <p:nvPr/>
         </p:nvSpPr>
@@ -7960,7 +8065,7 @@
       </p:sp>
       <p:sp>
         <p:nvSpPr>
-          <p:cNvPr id="26" name="TextBox 25"/>
+          <p:cNvPr id="29" name="TextBox 28"/>
           <p:cNvSpPr txBox="1"/>
           <p:nvPr/>
         </p:nvSpPr>
@@ -7993,7 +8098,7 @@
       </p:sp>
       <p:sp>
         <p:nvSpPr>
-          <p:cNvPr id="27" name="TextBox 26"/>
+          <p:cNvPr id="30" name="TextBox 29"/>
           <p:cNvSpPr txBox="1"/>
           <p:nvPr/>
         </p:nvSpPr>
@@ -8029,7 +8134,7 @@
       </p:sp>
       <p:sp>
         <p:nvSpPr>
-          <p:cNvPr id="28" name="TextBox 27"/>
+          <p:cNvPr id="31" name="TextBox 30"/>
           <p:cNvSpPr txBox="1"/>
           <p:nvPr/>
         </p:nvSpPr>
@@ -8065,7 +8170,7 @@
       </p:sp>
       <p:sp>
         <p:nvSpPr>
-          <p:cNvPr id="29" name="TextBox 28"/>
+          <p:cNvPr id="32" name="TextBox 31"/>
           <p:cNvSpPr txBox="1"/>
           <p:nvPr/>
         </p:nvSpPr>
@@ -8101,7 +8206,7 @@
       </p:sp>
       <p:sp>
         <p:nvSpPr>
-          <p:cNvPr id="30" name="TextBox 29"/>
+          <p:cNvPr id="33" name="TextBox 32"/>
           <p:cNvSpPr txBox="1"/>
           <p:nvPr/>
         </p:nvSpPr>
@@ -8137,7 +8242,7 @@
       </p:sp>
       <p:sp>
         <p:nvSpPr>
-          <p:cNvPr id="31" name="TextBox 30"/>
+          <p:cNvPr id="34" name="TextBox 33"/>
           <p:cNvSpPr txBox="1"/>
           <p:nvPr/>
         </p:nvSpPr>
@@ -8173,7 +8278,7 @@
       </p:sp>
       <p:sp>
         <p:nvSpPr>
-          <p:cNvPr id="32" name="Rounded Rectangle 31"/>
+          <p:cNvPr id="35" name="Rounded Rectangle 34"/>
           <p:cNvSpPr/>
           <p:nvPr/>
         </p:nvSpPr>
@@ -8218,7 +8323,7 @@
       </p:sp>
       <p:sp>
         <p:nvSpPr>
-          <p:cNvPr id="33" name="TextBox 32"/>
+          <p:cNvPr id="36" name="TextBox 35"/>
           <p:cNvSpPr txBox="1"/>
           <p:nvPr/>
         </p:nvSpPr>
@@ -8254,7 +8359,7 @@
       </p:sp>
       <p:sp>
         <p:nvSpPr>
-          <p:cNvPr id="34" name="TextBox 33"/>
+          <p:cNvPr id="37" name="TextBox 36"/>
           <p:cNvSpPr txBox="1"/>
           <p:nvPr/>
         </p:nvSpPr>
@@ -8290,7 +8395,7 @@
       </p:sp>
       <p:sp>
         <p:nvSpPr>
-          <p:cNvPr id="35" name="Rectangle 34"/>
+          <p:cNvPr id="38" name="Rectangle 37"/>
           <p:cNvSpPr/>
           <p:nvPr/>
         </p:nvSpPr>
@@ -8333,7 +8438,7 @@
       </p:sp>
       <p:sp>
         <p:nvSpPr>
-          <p:cNvPr id="36" name="TextBox 35"/>
+          <p:cNvPr id="39" name="TextBox 38"/>
           <p:cNvSpPr txBox="1"/>
           <p:nvPr/>
         </p:nvSpPr>
@@ -8369,7 +8474,7 @@
       </p:sp>
       <p:sp>
         <p:nvSpPr>
-          <p:cNvPr id="37" name="TextBox 36"/>
+          <p:cNvPr id="40" name="TextBox 39"/>
           <p:cNvSpPr txBox="1"/>
           <p:nvPr/>
         </p:nvSpPr>
@@ -8405,7 +8510,7 @@
       </p:sp>
       <p:sp>
         <p:nvSpPr>
-          <p:cNvPr id="38" name="TextBox 37"/>
+          <p:cNvPr id="41" name="TextBox 40"/>
           <p:cNvSpPr txBox="1"/>
           <p:nvPr/>
         </p:nvSpPr>
@@ -8441,7 +8546,7 @@
       </p:sp>
       <p:sp>
         <p:nvSpPr>
-          <p:cNvPr id="39" name="TextBox 38"/>
+          <p:cNvPr id="42" name="TextBox 41"/>
           <p:cNvSpPr txBox="1"/>
           <p:nvPr/>
         </p:nvSpPr>
@@ -8474,7 +8579,7 @@
       </p:sp>
       <p:sp>
         <p:nvSpPr>
-          <p:cNvPr id="40" name="TextBox 39"/>
+          <p:cNvPr id="43" name="TextBox 42"/>
           <p:cNvSpPr txBox="1"/>
           <p:nvPr/>
         </p:nvSpPr>
@@ -8510,7 +8615,7 @@
       </p:sp>
       <p:sp>
         <p:nvSpPr>
-          <p:cNvPr id="41" name="TextBox 40"/>
+          <p:cNvPr id="44" name="TextBox 43"/>
           <p:cNvSpPr txBox="1"/>
           <p:nvPr/>
         </p:nvSpPr>
@@ -8546,7 +8651,7 @@
       </p:sp>
       <p:sp>
         <p:nvSpPr>
-          <p:cNvPr id="42" name="TextBox 41"/>
+          <p:cNvPr id="45" name="TextBox 44"/>
           <p:cNvSpPr txBox="1"/>
           <p:nvPr/>
         </p:nvSpPr>
@@ -8582,7 +8687,7 @@
       </p:sp>
       <p:sp>
         <p:nvSpPr>
-          <p:cNvPr id="43" name="TextBox 42"/>
+          <p:cNvPr id="46" name="TextBox 45"/>
           <p:cNvSpPr txBox="1"/>
           <p:nvPr/>
         </p:nvSpPr>
@@ -8618,7 +8723,7 @@
       </p:sp>
       <p:sp>
         <p:nvSpPr>
-          <p:cNvPr id="44" name="TextBox 43"/>
+          <p:cNvPr id="47" name="TextBox 46"/>
           <p:cNvSpPr txBox="1"/>
           <p:nvPr/>
         </p:nvSpPr>
@@ -8654,7 +8759,7 @@
       </p:sp>
       <p:sp>
         <p:nvSpPr>
-          <p:cNvPr id="45" name="Rectangle 44"/>
+          <p:cNvPr id="48" name="Rectangle 47"/>
           <p:cNvSpPr/>
           <p:nvPr/>
         </p:nvSpPr>
@@ -8697,7 +8802,7 @@
       </p:sp>
       <p:sp>
         <p:nvSpPr>
-          <p:cNvPr id="46" name="TextBox 45"/>
+          <p:cNvPr id="49" name="TextBox 48"/>
           <p:cNvSpPr txBox="1"/>
           <p:nvPr/>
         </p:nvSpPr>
@@ -8733,7 +8838,7 @@
       </p:sp>
       <p:sp>
         <p:nvSpPr>
-          <p:cNvPr id="47" name="TextBox 46"/>
+          <p:cNvPr id="50" name="TextBox 49"/>
           <p:cNvSpPr txBox="1"/>
           <p:nvPr/>
         </p:nvSpPr>
@@ -8769,7 +8874,7 @@
       </p:sp>
       <p:sp>
         <p:nvSpPr>
-          <p:cNvPr id="48" name="TextBox 47"/>
+          <p:cNvPr id="51" name="TextBox 50"/>
           <p:cNvSpPr txBox="1"/>
           <p:nvPr/>
         </p:nvSpPr>
@@ -8805,7 +8910,7 @@
       </p:sp>
       <p:sp>
         <p:nvSpPr>
-          <p:cNvPr id="49" name="TextBox 48"/>
+          <p:cNvPr id="52" name="TextBox 51"/>
           <p:cNvSpPr txBox="1"/>
           <p:nvPr/>
         </p:nvSpPr>
@@ -8841,7 +8946,7 @@
       </p:sp>
       <p:sp>
         <p:nvSpPr>
-          <p:cNvPr id="50" name="TextBox 49"/>
+          <p:cNvPr id="53" name="TextBox 52"/>
           <p:cNvSpPr txBox="1"/>
           <p:nvPr/>
         </p:nvSpPr>
@@ -8877,7 +8982,7 @@
       </p:sp>
       <p:sp>
         <p:nvSpPr>
-          <p:cNvPr id="51" name="TextBox 50"/>
+          <p:cNvPr id="54" name="TextBox 53"/>
           <p:cNvSpPr txBox="1"/>
           <p:nvPr/>
         </p:nvSpPr>
@@ -8913,7 +9018,7 @@
       </p:sp>
       <p:sp>
         <p:nvSpPr>
-          <p:cNvPr id="52" name="Rounded Rectangle 51"/>
+          <p:cNvPr id="55" name="Rounded Rectangle 54"/>
           <p:cNvSpPr/>
           <p:nvPr/>
         </p:nvSpPr>
@@ -8958,7 +9063,7 @@
       </p:sp>
       <p:sp>
         <p:nvSpPr>
-          <p:cNvPr id="53" name="TextBox 52"/>
+          <p:cNvPr id="56" name="TextBox 55"/>
           <p:cNvSpPr txBox="1"/>
           <p:nvPr/>
         </p:nvSpPr>
@@ -8994,7 +9099,7 @@
       </p:sp>
       <p:sp>
         <p:nvSpPr>
-          <p:cNvPr id="54" name="Rounded Rectangle 53"/>
+          <p:cNvPr id="57" name="Rounded Rectangle 56"/>
           <p:cNvSpPr/>
           <p:nvPr/>
         </p:nvSpPr>
@@ -9039,7 +9144,7 @@
       </p:sp>
       <p:sp>
         <p:nvSpPr>
-          <p:cNvPr id="55" name="TextBox 54"/>
+          <p:cNvPr id="58" name="TextBox 57"/>
           <p:cNvSpPr txBox="1"/>
           <p:nvPr/>
         </p:nvSpPr>
@@ -9208,7 +9313,7 @@
               </a:defRPr>
             </a:pPr>
             <a:r>
-              <a:t>The Visibility Layer — Every Interaction Generates Data</a:t>
+              <a:t>Same Data. Two Audiences.</a:t>
             </a:r>
           </a:p>
         </p:txBody>
@@ -10966,7 +11071,7 @@
               </a:defRPr>
             </a:pPr>
             <a:r>
-              <a:t>Next Steps</a:t>
+              <a:t>Next Step: Pilot in Two Weeks</a:t>
             </a:r>
           </a:p>
         </p:txBody>
@@ -11541,7 +11646,7 @@
               </a:defRPr>
             </a:pPr>
             <a:r>
-              <a:t>"Visibility is the common ground. Start visible, stay visible, scale on evidence."</a:t>
+              <a:t>"Start visible. Stay visible. Scale on evidence."</a:t>
             </a:r>
           </a:p>
         </p:txBody>

</xml_diff>

<commit_message>
Standardize demo surfaces, repo name, and dashboard references
- Replace "Codex web" / codex.openai.com with "Codex desktop app"
- Replace "RetailPOS" with "JavaPOS (javapos-contracts)" across all scripts
- Standardize dashboard on visibility.html (static HTML)
- Update loom checklist demo surfaces for desktop app workflow
- Regenerate PPTX from updated generator
- Sync all local-only files to GitHub

Fixes 6 issues from DEMO_SYNC_REQUIREMENTS_2.md

Co-Authored-By: Claude Opus 4.6 <noreply@anthropic.com>
</commit_message>
<xml_diff>
--- a/codex/codex_enablement_v2.pptx
+++ b/codex/codex_enablement_v2.pptx
@@ -3211,7 +3211,7 @@
               </a:defRPr>
             </a:pPr>
             <a:r>
-              <a:t>Engineering Visibility</a:t>
+              <a:t>Governed Codex Adoption</a:t>
             </a:r>
           </a:p>
         </p:txBody>
@@ -3290,7 +3290,7 @@
               </a:defRPr>
             </a:pPr>
             <a:r>
-              <a:t>How Codex Makes Your Codebase — and Your Engineering — Visible</a:t>
+              <a:t>Improve code understanding, quality, and onboarding without losing control</a:t>
             </a:r>
           </a:p>
         </p:txBody>
@@ -3750,7 +3750,7 @@
               </a:defRPr>
             </a:pPr>
             <a:r>
-              <a:t>•  Prior AI tool rollout ended in a security incident</a:t>
+              <a:t>•  Prior tool rollouts stalled due to uneven adoption and weak governance</a:t>
             </a:r>
           </a:p>
           <a:p>
@@ -3984,7 +3984,7 @@
               </a:defRPr>
             </a:pPr>
             <a:r>
-              <a:t>→  Invisible impact → business can't justify</a:t>
+              <a:t>→  Invisible impact → leadership can't justify scale</a:t>
             </a:r>
           </a:p>
         </p:txBody>
@@ -4065,7 +4065,7 @@
               </a:defRPr>
             </a:pPr>
             <a:r>
-              <a:t>All four problems share one root cause: invisibility. Codex doesn't just write code — it generates the data that makes engineering visible.</a:t>
+              <a:t>All four problems share one root cause: invisibility. Codex helps teams work in the codebase while giving leadership evidence to govern rollout.</a:t>
             </a:r>
           </a:p>
         </p:txBody>
@@ -4205,7 +4205,7 @@
               </a:defRPr>
             </a:pPr>
             <a:r>
-              <a:t>Agentic. Sandboxed. Every Action Audited.</a:t>
+              <a:t>Codex in the Workflow: Local Context, Managed Controls</a:t>
             </a:r>
           </a:p>
         </p:txBody>
@@ -4527,7 +4527,7 @@
               </a:defRPr>
             </a:pPr>
             <a:r>
-              <a:t>Codex CLI (Open-Source Rust)</a:t>
+              <a:t>Codex</a:t>
             </a:r>
           </a:p>
         </p:txBody>
@@ -4918,7 +4918,7 @@
               </a:defRPr>
             </a:pPr>
             <a:r>
-              <a:t>GPT-5.4 (1M context)</a:t>
+              <a:t>OpenAI Models</a:t>
             </a:r>
           </a:p>
         </p:txBody>
@@ -5075,7 +5075,7 @@
             </a:r>
             <a:br/>
             <a:r>
-              <a:t>•  RBAC + Compliance API + audit trails</a:t>
+              <a:t>•  RBAC + audit logging + usage reporting</a:t>
             </a:r>
             <a:br/>
             <a:r>
@@ -5083,7 +5083,7 @@
             </a:r>
             <a:br/>
             <a:r>
-              <a:t>•  requirements.toml — cloud-managed policies</a:t>
+              <a:t>•  Central policy controls</a:t>
             </a:r>
           </a:p>
         </p:txBody>
@@ -5164,7 +5164,7 @@
               </a:defRPr>
             </a:pPr>
             <a:r>
-              <a:t>Codex is governed AND visible. Open-source CLI, auditable, Compliance API. Part of OpenAI's enterprise suite alongside ChatGPT Enterprise + API + Frontier.</a:t>
+              <a:t>Codex is governed and observable. Teams work locally, leadership gets rollout evidence. Part of OpenAI's enterprise suite alongside ChatGPT Enterprise + API + Frontier.</a:t>
             </a:r>
           </a:p>
         </p:txBody>
@@ -5245,7 +5245,7 @@
               </a:defRPr>
             </a:pPr>
             <a:r>
-              <a:t>VP Assurance: Source code stays on the developer machine. Only relevant context reaches the API. Kernel-level sandbox blocks unauthorized access.</a:t>
+              <a:t>VP Assurance: use a managed environment, central guardrails, and phased permissions so adoption can scale safely.</a:t>
             </a:r>
           </a:p>
         </p:txBody>
@@ -5990,7 +5990,7 @@
               </a:defRPr>
             </a:pPr>
             <a:r>
-              <a:t>requirements.toml</a:t>
+              <a:t>Org Policy Layer</a:t>
             </a:r>
           </a:p>
         </p:txBody>
@@ -6026,7 +6026,7 @@
               </a:defRPr>
             </a:pPr>
             <a:r>
-              <a:t>Cloud-managed guardrails</a:t>
+              <a:t>Central guardrails</a:t>
             </a:r>
           </a:p>
         </p:txBody>
@@ -6249,7 +6249,7 @@
               </a:defRPr>
             </a:pPr>
             <a:r>
-              <a:t>•  Audit-friendly: policy = code</a:t>
+              <a:t>•  Versioned and reviewable</a:t>
             </a:r>
           </a:p>
         </p:txBody>
@@ -7021,7 +7021,7 @@
               </a:defRPr>
             </a:pPr>
             <a:r>
-              <a:t>OpenAI built 1 million lines of production code using this exact harness in 5 months. The open-source CLI is auditable.</a:t>
+              <a:t>The harness makes rollout governable: local team instructions, central guardrails, and phased permissions.</a:t>
             </a:r>
           </a:p>
         </p:txBody>
@@ -7754,7 +7754,7 @@
               </a:defRPr>
             </a:pPr>
             <a:r>
-              <a:t>Cisco: 1,500 hrs/month saved</a:t>
+              <a:t>Why it wins:</a:t>
             </a:r>
           </a:p>
         </p:txBody>
@@ -7790,7 +7790,7 @@
               </a:defRPr>
             </a:pPr>
             <a:r>
-              <a:t>Onboarding: 91→49 days (DX Research)</a:t>
+              <a:t>  ✓  Immediate value for onboarding and legacy code</a:t>
             </a:r>
           </a:p>
         </p:txBody>
@@ -10931,7 +10931,7 @@
               </a:defRPr>
             </a:pPr>
             <a:r>
-              <a:t>We built this dashboard in 48 hours using Codex.</a:t>
+              <a:t>Example pilot view: adoption, risk, and workflow mix in one place.</a:t>
             </a:r>
           </a:p>
         </p:txBody>
@@ -11416,7 +11416,7 @@
               </a:defRPr>
             </a:pPr>
             <a:r>
-              <a:t>Joint session with your security team and OpenAI to configure requirements.toml, SSO integration, data classification, and audit policies. Security is a partner, not a gate.</a:t>
+              <a:t>Joint session with your security team and OpenAI to configure policy controls, SSO integration, data classification, and audit expectations. Security is a partner, not a gate.</a:t>
             </a:r>
           </a:p>
         </p:txBody>

</xml_diff>